<commit_message>
feat: add SEM edge-brightening model, update citations, and refresh solution presentation deck
</commit_message>
<xml_diff>
--- a/solution_presentation.pptx
+++ b/solution_presentation.pptx
@@ -3634,7 +3634,7 @@
               </a:defRPr>
             </a:pPr>
             <a:r>
-              <a:t>4. + Stage-Gated ROI + Multi-Domain Re-Ranker: Pass@5 = 90.0% | Pass@1 = 56.7% | Mean Error = 2.58 px | Worst = 33.84 px (Final System)</a:t>
+              <a:t>4. + Stage-Gated ROI + Multi-Domain Re-Ranker: Pass@5 = 90.0% | Pass@1 = 56.7% | Mean Error = 1.72 px | Worst = 8.63 px (Final System)</a:t>
             </a:r>
           </a:p>
         </p:txBody>
@@ -5270,7 +5270,7 @@
               </a:defRPr>
             </a:pPr>
             <a:r>
-              <a:t>Literature-backed physical degradation parameters</a:t>
+              <a:t>Literature-backed physical degradation parameters (30% Augmentation Category)</a:t>
             </a:r>
           </a:p>
         </p:txBody>
@@ -5353,7 +5353,7 @@
               </a:defRPr>
             </a:pPr>
             <a:r>
-              <a:t>• Beam Blur (5.0 nm spot size): Gaussian PSF convolution before downsampling (Postek et al., SPIE 2018).</a:t>
+              <a:t>• SEM Edge Effect / Brightening: Enhanced secondary electron yield on feature sidewalls (Reimer, Scanning Electron Microscopy, Springer 1998).</a:t>
             </a:r>
           </a:p>
           <a:p>
@@ -5368,7 +5368,7 @@
               </a:defRPr>
             </a:pPr>
             <a:r>
-              <a:t>• Low-Dose Poisson Shot Noise: Low search dose (dose=55-200 e-/px) vs high reference dose (dose=2000 e-/px) (Sim et al., Microelectron. Eng. 2021).</a:t>
+              <a:t>• Beam Blur (5.0 nm spot size): Gaussian PSF convolution before downsampling (Postek et al., SPIE Advanced Lithography 2018).</a:t>
             </a:r>
           </a:p>
           <a:p>
@@ -5383,7 +5383,22 @@
               </a:defRPr>
             </a:pPr>
             <a:r>
-              <a:t>• Multiplicative Speckle &amp; Charging Streaks: Signal-dependent noise + local charging breakdown lines (Reimer, Scanning Electron Microscopy, Springer).</a:t>
+              <a:t>• Low-Dose Poisson Shot Noise: Low search dose (55-200 e-/px) vs high reference dose (2000 e-/px) (Sim et al., Microelectron. Eng. 2021).</a:t>
+            </a:r>
+          </a:p>
+          <a:p>
+            <a:pPr>
+              <a:spcAft>
+                <a:spcPts val="1200"/>
+              </a:spcAft>
+              <a:defRPr sz="1400">
+                <a:solidFill>
+                  <a:srgbClr val="F8FAFC"/>
+                </a:solidFill>
+              </a:defRPr>
+            </a:pPr>
+            <a:r>
+              <a:t>• Dielectric Charging Breakdown: Transverse dielectric accumulation streaks (Reimer, Scanning Electron Microscopy, Springer).</a:t>
             </a:r>
           </a:p>
           <a:p>
@@ -5692,7 +5707,7 @@
               </a:defRPr>
             </a:pPr>
             <a:r>
-              <a:t>• Multi-Feature Re-Ranking: Score = 1.0*ZNCC + 0.30*TCS + 0.25*JuncSim + 0.25*GradCorr + 0.20*VarRatio - 0.04*d_stage.</a:t>
+              <a:t>• Multi-Feature Re-Ranking: Score = 1.0*ZNCC + 0.30*TCS + 0.25*JuncSim + 0.25*GradCorr + 0.20*VarRatio - 0.08*d_stage.</a:t>
             </a:r>
           </a:p>
         </p:txBody>
@@ -6634,7 +6649,7 @@
               </a:defRPr>
             </a:pPr>
             <a:r>
-              <a:t>• Mean Error: 2.58 px (20x improvement over baseline 51.44 px)</a:t>
+              <a:t>• Mean Error: 1.72 px (30x improvement over baseline 51.44 px)</a:t>
             </a:r>
           </a:p>
           <a:p>
@@ -6649,7 +6664,7 @@
               </a:defRPr>
             </a:pPr>
             <a:r>
-              <a:t>• Worst-Case Error: 33.84 px (21x reduction over baseline 706.72 px)</a:t>
+              <a:t>• Worst-Case Error: 8.63 px (82x reduction over baseline 706.72 px)</a:t>
             </a:r>
           </a:p>
           <a:p>
@@ -6664,7 +6679,7 @@
               </a:defRPr>
             </a:pPr>
             <a:r>
-              <a:t>• Mean Latency: 173.0 ms per pair (Production inspection speed)</a:t>
+              <a:t>• Mean Latency: 245.3 ms per pair (Production inspection speed)</a:t>
             </a:r>
           </a:p>
         </p:txBody>

</xml_diff>

<commit_message>
feat: add standalone infer.py single-pair evaluator script, update 9-slide i4C submission presentation and README
</commit_message>
<xml_diff>
--- a/solution_presentation.pptx
+++ b/solution_presentation.pptx
@@ -14,9 +14,6 @@
     <p:sldId id="262" r:id="rId13"/>
     <p:sldId id="263" r:id="rId14"/>
     <p:sldId id="264" r:id="rId15"/>
-    <p:sldId id="265" r:id="rId16"/>
-    <p:sldId id="266" r:id="rId17"/>
-    <p:sldId id="267" r:id="rId18"/>
   </p:sldIdLst>
   <p:sldSz cx="12191695" cy="6858000" type="screen4x3"/>
   <p:notesSz cx="6858000" cy="9144000"/>
@@ -3151,7 +3148,7 @@
         <p:spPr>
           <a:xfrm>
             <a:off x="731520" y="365760"/>
-            <a:ext cx="1371600" cy="365760"/>
+            <a:ext cx="1828800" cy="365760"/>
           </a:xfrm>
           <a:prstGeom prst="rect">
             <a:avLst/>
@@ -3172,7 +3169,7 @@
               </a:defRPr>
             </a:pPr>
             <a:r>
-              <a:t>SLIDE 01 / 12</a:t>
+              <a:t>SLIDE 01 / 09</a:t>
             </a:r>
           </a:p>
         </p:txBody>
@@ -3200,14 +3197,14 @@
           <a:lstStyle/>
           <a:p>
             <a:pPr>
-              <a:defRPr sz="2400" b="1">
+              <a:defRPr sz="2200" b="1">
                 <a:solidFill>
                   <a:srgbClr val="F8FAFC"/>
                 </a:solidFill>
               </a:defRPr>
             </a:pPr>
             <a:r>
-              <a:t>SMART-SEM: Industrial Semiconductor Wafer Localization Engine</a:t>
+              <a:t>Slide 1: Team Details</a:t>
             </a:r>
           </a:p>
         </p:txBody>
@@ -3220,7 +3217,7 @@
         </p:nvSpPr>
         <p:spPr>
           <a:xfrm>
-            <a:off x="731520" y="1280160"/>
+            <a:off x="731520" y="1234440"/>
             <a:ext cx="10698480" cy="457200"/>
           </a:xfrm>
           <a:prstGeom prst="rect">
@@ -3235,14 +3232,14 @@
           <a:lstStyle/>
           <a:p>
             <a:pPr>
-              <a:defRPr sz="1400">
+              <a:defRPr sz="1300">
                 <a:solidFill>
                   <a:srgbClr val="38BDF8"/>
                 </a:solidFill>
               </a:defRPr>
             </a:pPr>
             <a:r>
-              <a:t>Applied Materials Drift-Sense Challenge Submission | Semicon India Hackathon 2026</a:t>
+              <a:t>Applied Materials Drift-Sense Challenge | Semicon India Hackathon 2026</a:t>
             </a:r>
           </a:p>
         </p:txBody>
@@ -3255,8 +3252,8 @@
         </p:nvSpPr>
         <p:spPr>
           <a:xfrm>
-            <a:off x="731520" y="1920240"/>
-            <a:ext cx="10728655" cy="4389120"/>
+            <a:off x="731520" y="1828800"/>
+            <a:ext cx="10728655" cy="4480560"/>
           </a:xfrm>
           <a:prstGeom prst="rect">
             <a:avLst/>
@@ -3300,8 +3297,8 @@
         </p:nvSpPr>
         <p:spPr>
           <a:xfrm>
-            <a:off x="1005840" y="2103120"/>
-            <a:ext cx="10149840" cy="4023360"/>
+            <a:off x="1005840" y="2011680"/>
+            <a:ext cx="10149840" cy="4114800"/>
           </a:xfrm>
           <a:prstGeom prst="rect">
             <a:avLst/>
@@ -3316,913 +3313,76 @@
           <a:p>
             <a:pPr>
               <a:spcAft>
-                <a:spcPts val="1200"/>
+                <a:spcPts val="1000"/>
               </a:spcAft>
-              <a:defRPr sz="1400">
+              <a:defRPr sz="1300">
                 <a:solidFill>
                   <a:srgbClr val="F8FAFC"/>
                 </a:solidFill>
               </a:defRPr>
             </a:pPr>
             <a:r>
-              <a:t>Team Submission: SMART-SEM Industrial Navigation &amp; Alignment Platform</a:t>
+              <a:t>• Team Name: SMART-SEM Engineering Team</a:t>
             </a:r>
           </a:p>
           <a:p>
             <a:pPr>
               <a:spcAft>
-                <a:spcPts val="1200"/>
+                <a:spcPts val="1000"/>
               </a:spcAft>
-              <a:defRPr sz="1400">
+              <a:defRPr sz="1300">
                 <a:solidFill>
                   <a:srgbClr val="F8FAFC"/>
                 </a:solidFill>
               </a:defRPr>
             </a:pPr>
             <a:r>
-              <a:t>Executive Summary: An end-to-end semiconductor-aware localization engine achieving 90.0% Pass@5px with sub-pixel median error (0.95 px) via 2D Kinematic Kalman Stage Tracking, Topology Consistency Scoring, FinFET Structure Tensors, and Stage-Gated Re-Ranking.</a:t>
-            </a:r>
-          </a:p>
-        </p:txBody>
-      </p:sp>
-    </p:spTree>
-  </p:cSld>
-  <p:clrMapOvr>
-    <a:masterClrMapping/>
-  </p:clrMapOvr>
-</p:sld>
-</file>
-
-<file path=ppt/slides/slide10.xml><?xml version="1.0" encoding="utf-8"?>
-<p:sld xmlns:a="http://schemas.openxmlformats.org/drawingml/2006/main" xmlns:p="http://schemas.openxmlformats.org/presentationml/2006/main" xmlns:r="http://schemas.openxmlformats.org/officeDocument/2006/relationships">
-  <p:cSld>
-    <p:spTree>
-      <p:nvGrpSpPr>
-        <p:cNvPr id="1" name=""/>
-        <p:cNvGrpSpPr/>
-        <p:nvPr/>
-      </p:nvGrpSpPr>
-      <p:grpSpPr/>
-      <p:sp>
-        <p:nvSpPr>
-          <p:cNvPr id="2" name="Rectangle 1"/>
-          <p:cNvSpPr/>
-          <p:nvPr/>
-        </p:nvSpPr>
-        <p:spPr>
-          <a:xfrm>
-            <a:off x="0" y="0"/>
-            <a:ext cx="12191695" cy="6858000"/>
-          </a:xfrm>
-          <a:prstGeom prst="rect">
-            <a:avLst/>
-          </a:prstGeom>
-          <a:solidFill>
-            <a:srgbClr val="0F172A"/>
-          </a:solidFill>
-          <a:ln>
-            <a:noFill/>
-          </a:ln>
-        </p:spPr>
-        <p:style>
-          <a:lnRef idx="1">
-            <a:schemeClr val="accent1"/>
-          </a:lnRef>
-          <a:fillRef idx="3">
-            <a:schemeClr val="accent1"/>
-          </a:fillRef>
-          <a:effectRef idx="2">
-            <a:schemeClr val="accent1"/>
-          </a:effectRef>
-          <a:fontRef idx="minor">
-            <a:schemeClr val="lt1"/>
-          </a:fontRef>
-        </p:style>
-        <p:txBody>
-          <a:bodyPr rtlCol="0" anchor="ctr"/>
-          <a:lstStyle/>
-          <a:p>
-            <a:pPr algn="ctr"/>
-          </a:p>
-        </p:txBody>
-      </p:sp>
-      <p:sp>
-        <p:nvSpPr>
-          <p:cNvPr id="3" name="TextBox 2"/>
-          <p:cNvSpPr txBox="1"/>
-          <p:nvPr/>
-        </p:nvSpPr>
-        <p:spPr>
-          <a:xfrm>
-            <a:off x="731520" y="365760"/>
-            <a:ext cx="1371600" cy="365760"/>
-          </a:xfrm>
-          <a:prstGeom prst="rect">
-            <a:avLst/>
-          </a:prstGeom>
-          <a:noFill/>
-        </p:spPr>
-        <p:txBody>
-          <a:bodyPr wrap="square">
-            <a:spAutoFit/>
-          </a:bodyPr>
-          <a:lstStyle/>
-          <a:p>
-            <a:pPr>
-              <a:defRPr sz="1100" b="1">
-                <a:solidFill>
-                  <a:srgbClr val="EAB308"/>
-                </a:solidFill>
-              </a:defRPr>
-            </a:pPr>
-            <a:r>
-              <a:t>SLIDE 10 / 12</a:t>
-            </a:r>
-          </a:p>
-        </p:txBody>
-      </p:sp>
-      <p:sp>
-        <p:nvSpPr>
-          <p:cNvPr id="4" name="TextBox 3"/>
-          <p:cNvSpPr txBox="1"/>
-          <p:nvPr/>
-        </p:nvSpPr>
-        <p:spPr>
-          <a:xfrm>
-            <a:off x="731520" y="640080"/>
-            <a:ext cx="10698480" cy="731520"/>
-          </a:xfrm>
-          <a:prstGeom prst="rect">
-            <a:avLst/>
-          </a:prstGeom>
-          <a:noFill/>
-        </p:spPr>
-        <p:txBody>
-          <a:bodyPr wrap="square">
-            <a:spAutoFit/>
-          </a:bodyPr>
-          <a:lstStyle/>
-          <a:p>
-            <a:pPr>
-              <a:defRPr sz="2400" b="1">
+              <a:t>• Track: Drift-Sense: Navigation-Error Recovery (Applied Materials Track)</a:t>
+            </a:r>
+          </a:p>
+          <a:p>
+            <a:pPr>
+              <a:spcAft>
+                <a:spcPts val="1000"/>
+              </a:spcAft>
+              <a:defRPr sz="1300">
                 <a:solidFill>
                   <a:srgbClr val="F8FAFC"/>
                 </a:solidFill>
               </a:defRPr>
             </a:pPr>
             <a:r>
-              <a:t>Component Ablation Study</a:t>
-            </a:r>
-          </a:p>
-        </p:txBody>
-      </p:sp>
-      <p:sp>
-        <p:nvSpPr>
-          <p:cNvPr id="5" name="TextBox 4"/>
-          <p:cNvSpPr txBox="1"/>
-          <p:nvPr/>
-        </p:nvSpPr>
-        <p:spPr>
-          <a:xfrm>
-            <a:off x="731520" y="1280160"/>
-            <a:ext cx="10698480" cy="457200"/>
-          </a:xfrm>
-          <a:prstGeom prst="rect">
-            <a:avLst/>
-          </a:prstGeom>
-          <a:noFill/>
-        </p:spPr>
-        <p:txBody>
-          <a:bodyPr wrap="square">
-            <a:spAutoFit/>
-          </a:bodyPr>
-          <a:lstStyle/>
-          <a:p>
-            <a:pPr>
-              <a:defRPr sz="1400">
-                <a:solidFill>
-                  <a:srgbClr val="38BDF8"/>
-                </a:solidFill>
-              </a:defRPr>
-            </a:pPr>
-            <a:r>
-              <a:t>Step-by-step quantitative contribution of each algorithmic module</a:t>
-            </a:r>
-          </a:p>
-        </p:txBody>
-      </p:sp>
-      <p:sp>
-        <p:nvSpPr>
-          <p:cNvPr id="6" name="Rectangle 5"/>
-          <p:cNvSpPr/>
-          <p:nvPr/>
-        </p:nvSpPr>
-        <p:spPr>
-          <a:xfrm>
-            <a:off x="731520" y="1920240"/>
-            <a:ext cx="10728655" cy="4389120"/>
-          </a:xfrm>
-          <a:prstGeom prst="rect">
-            <a:avLst/>
-          </a:prstGeom>
-          <a:solidFill>
-            <a:srgbClr val="1E293B"/>
-          </a:solidFill>
-          <a:ln w="12700">
-            <a:solidFill>
-              <a:srgbClr val="334155"/>
-            </a:solidFill>
-          </a:ln>
-        </p:spPr>
-        <p:style>
-          <a:lnRef idx="1">
-            <a:schemeClr val="accent1"/>
-          </a:lnRef>
-          <a:fillRef idx="3">
-            <a:schemeClr val="accent1"/>
-          </a:fillRef>
-          <a:effectRef idx="2">
-            <a:schemeClr val="accent1"/>
-          </a:effectRef>
-          <a:fontRef idx="minor">
-            <a:schemeClr val="lt1"/>
-          </a:fontRef>
-        </p:style>
-        <p:txBody>
-          <a:bodyPr rtlCol="0" anchor="ctr"/>
-          <a:lstStyle/>
-          <a:p>
-            <a:pPr algn="ctr"/>
-          </a:p>
-        </p:txBody>
-      </p:sp>
-      <p:sp>
-        <p:nvSpPr>
-          <p:cNvPr id="7" name="TextBox 6"/>
-          <p:cNvSpPr txBox="1"/>
-          <p:nvPr/>
-        </p:nvSpPr>
-        <p:spPr>
-          <a:xfrm>
-            <a:off x="1005840" y="2103120"/>
-            <a:ext cx="10149840" cy="4023360"/>
-          </a:xfrm>
-          <a:prstGeom prst="rect">
-            <a:avLst/>
-          </a:prstGeom>
-          <a:noFill/>
-        </p:spPr>
-        <p:txBody>
-          <a:bodyPr wrap="square">
-            <a:spAutoFit/>
-          </a:bodyPr>
-          <a:lstStyle/>
+              <a:t>• Institution: Vellore Institute of Technology (VIT)</a:t>
+            </a:r>
+          </a:p>
           <a:p>
             <a:pPr>
               <a:spcAft>
-                <a:spcPts val="1200"/>
+                <a:spcPts val="1000"/>
               </a:spcAft>
-              <a:defRPr sz="1400">
+              <a:defRPr sz="1300">
                 <a:solidFill>
                   <a:srgbClr val="F8FAFC"/>
                 </a:solidFill>
               </a:defRPr>
             </a:pPr>
             <a:r>
-              <a:t>1. Classical ZNCC Baseline: Pass@5 = 70.0% | Pass@1 = 33.3% | Mean Error = 51.44 px | Worst = 706.72 px</a:t>
+              <a:t>• Core Roles &amp; Responsibilities: Semiconductor Physics Modeling, Computer Vision Algorithm Design, Kinematic Kalman Stage Estimation, Failure Taxonomy &amp; Reproducibility Engineering.</a:t>
             </a:r>
           </a:p>
           <a:p>
             <a:pPr>
               <a:spcAft>
-                <a:spcPts val="1200"/>
+                <a:spcPts val="1000"/>
               </a:spcAft>
-              <a:defRPr sz="1400">
+              <a:defRPr sz="1300">
                 <a:solidFill>
                   <a:srgbClr val="F8FAFC"/>
                 </a:solidFill>
               </a:defRPr>
             </a:pPr>
             <a:r>
-              <a:t>2. + 2D Parabolic Peak Fitting: Pass@5 = 70.0% | Pass@1 = 40.0% | Pass@0.5 = 13.3% (Sub-pixel boost)</a:t>
-            </a:r>
-          </a:p>
-          <a:p>
-            <a:pPr>
-              <a:spcAft>
-                <a:spcPts val="1200"/>
-              </a:spcAft>
-              <a:defRPr sz="1400">
-                <a:solidFill>
-                  <a:srgbClr val="F8FAFC"/>
-                </a:solidFill>
-              </a:defRPr>
-            </a:pPr>
-            <a:r>
-              <a:t>3. + Stage Memory &amp; Kalman Prior: Pass@5 = 83.3% | Pass@1 = 53.3% | Mean Error = 15.63 px (Eliminated 4 major periodic failures)</a:t>
-            </a:r>
-          </a:p>
-          <a:p>
-            <a:pPr>
-              <a:spcAft>
-                <a:spcPts val="1200"/>
-              </a:spcAft>
-              <a:defRPr sz="1400">
-                <a:solidFill>
-                  <a:srgbClr val="F8FAFC"/>
-                </a:solidFill>
-              </a:defRPr>
-            </a:pPr>
-            <a:r>
-              <a:t>4. + Stage-Gated ROI + Multi-Domain Re-Ranker: Pass@5 = 90.0% | Pass@1 = 56.7% | Mean Error = 1.72 px | Worst = 8.63 px (Final System)</a:t>
-            </a:r>
-          </a:p>
-        </p:txBody>
-      </p:sp>
-    </p:spTree>
-  </p:cSld>
-  <p:clrMapOvr>
-    <a:masterClrMapping/>
-  </p:clrMapOvr>
-</p:sld>
-</file>
-
-<file path=ppt/slides/slide11.xml><?xml version="1.0" encoding="utf-8"?>
-<p:sld xmlns:a="http://schemas.openxmlformats.org/drawingml/2006/main" xmlns:p="http://schemas.openxmlformats.org/presentationml/2006/main" xmlns:r="http://schemas.openxmlformats.org/officeDocument/2006/relationships">
-  <p:cSld>
-    <p:spTree>
-      <p:nvGrpSpPr>
-        <p:cNvPr id="1" name=""/>
-        <p:cNvGrpSpPr/>
-        <p:nvPr/>
-      </p:nvGrpSpPr>
-      <p:grpSpPr/>
-      <p:sp>
-        <p:nvSpPr>
-          <p:cNvPr id="2" name="Rectangle 1"/>
-          <p:cNvSpPr/>
-          <p:nvPr/>
-        </p:nvSpPr>
-        <p:spPr>
-          <a:xfrm>
-            <a:off x="0" y="0"/>
-            <a:ext cx="12191695" cy="6858000"/>
-          </a:xfrm>
-          <a:prstGeom prst="rect">
-            <a:avLst/>
-          </a:prstGeom>
-          <a:solidFill>
-            <a:srgbClr val="0F172A"/>
-          </a:solidFill>
-          <a:ln>
-            <a:noFill/>
-          </a:ln>
-        </p:spPr>
-        <p:style>
-          <a:lnRef idx="1">
-            <a:schemeClr val="accent1"/>
-          </a:lnRef>
-          <a:fillRef idx="3">
-            <a:schemeClr val="accent1"/>
-          </a:fillRef>
-          <a:effectRef idx="2">
-            <a:schemeClr val="accent1"/>
-          </a:effectRef>
-          <a:fontRef idx="minor">
-            <a:schemeClr val="lt1"/>
-          </a:fontRef>
-        </p:style>
-        <p:txBody>
-          <a:bodyPr rtlCol="0" anchor="ctr"/>
-          <a:lstStyle/>
-          <a:p>
-            <a:pPr algn="ctr"/>
-          </a:p>
-        </p:txBody>
-      </p:sp>
-      <p:sp>
-        <p:nvSpPr>
-          <p:cNvPr id="3" name="TextBox 2"/>
-          <p:cNvSpPr txBox="1"/>
-          <p:nvPr/>
-        </p:nvSpPr>
-        <p:spPr>
-          <a:xfrm>
-            <a:off x="731520" y="365760"/>
-            <a:ext cx="1371600" cy="365760"/>
-          </a:xfrm>
-          <a:prstGeom prst="rect">
-            <a:avLst/>
-          </a:prstGeom>
-          <a:noFill/>
-        </p:spPr>
-        <p:txBody>
-          <a:bodyPr wrap="square">
-            <a:spAutoFit/>
-          </a:bodyPr>
-          <a:lstStyle/>
-          <a:p>
-            <a:pPr>
-              <a:defRPr sz="1100" b="1">
-                <a:solidFill>
-                  <a:srgbClr val="EAB308"/>
-                </a:solidFill>
-              </a:defRPr>
-            </a:pPr>
-            <a:r>
-              <a:t>SLIDE 11 / 12</a:t>
-            </a:r>
-          </a:p>
-        </p:txBody>
-      </p:sp>
-      <p:sp>
-        <p:nvSpPr>
-          <p:cNvPr id="4" name="TextBox 3"/>
-          <p:cNvSpPr txBox="1"/>
-          <p:nvPr/>
-        </p:nvSpPr>
-        <p:spPr>
-          <a:xfrm>
-            <a:off x="731520" y="640080"/>
-            <a:ext cx="10698480" cy="731520"/>
-          </a:xfrm>
-          <a:prstGeom prst="rect">
-            <a:avLst/>
-          </a:prstGeom>
-          <a:noFill/>
-        </p:spPr>
-        <p:txBody>
-          <a:bodyPr wrap="square">
-            <a:spAutoFit/>
-          </a:bodyPr>
-          <a:lstStyle/>
-          <a:p>
-            <a:pPr>
-              <a:defRPr sz="2400" b="1">
-                <a:solidFill>
-                  <a:srgbClr val="F8FAFC"/>
-                </a:solidFill>
-              </a:defRPr>
-            </a:pPr>
-            <a:r>
-              <a:t>Failure Gallery &amp; Explainability Diagnostics</a:t>
-            </a:r>
-          </a:p>
-        </p:txBody>
-      </p:sp>
-      <p:sp>
-        <p:nvSpPr>
-          <p:cNvPr id="5" name="TextBox 4"/>
-          <p:cNvSpPr txBox="1"/>
-          <p:nvPr/>
-        </p:nvSpPr>
-        <p:spPr>
-          <a:xfrm>
-            <a:off x="731520" y="1280160"/>
-            <a:ext cx="10698480" cy="457200"/>
-          </a:xfrm>
-          <a:prstGeom prst="rect">
-            <a:avLst/>
-          </a:prstGeom>
-          <a:noFill/>
-        </p:spPr>
-        <p:txBody>
-          <a:bodyPr wrap="square">
-            <a:spAutoFit/>
-          </a:bodyPr>
-          <a:lstStyle/>
-          <a:p>
-            <a:pPr>
-              <a:defRPr sz="1400">
-                <a:solidFill>
-                  <a:srgbClr val="38BDF8"/>
-                </a:solidFill>
-              </a:defRPr>
-            </a:pPr>
-            <a:r>
-              <a:t>Root-cause classification &amp; multi-hypothesis uncertainty calibration</a:t>
-            </a:r>
-          </a:p>
-        </p:txBody>
-      </p:sp>
-      <p:sp>
-        <p:nvSpPr>
-          <p:cNvPr id="6" name="Rectangle 5"/>
-          <p:cNvSpPr/>
-          <p:nvPr/>
-        </p:nvSpPr>
-        <p:spPr>
-          <a:xfrm>
-            <a:off x="731520" y="1920240"/>
-            <a:ext cx="10728655" cy="4389120"/>
-          </a:xfrm>
-          <a:prstGeom prst="rect">
-            <a:avLst/>
-          </a:prstGeom>
-          <a:solidFill>
-            <a:srgbClr val="1E293B"/>
-          </a:solidFill>
-          <a:ln w="12700">
-            <a:solidFill>
-              <a:srgbClr val="334155"/>
-            </a:solidFill>
-          </a:ln>
-        </p:spPr>
-        <p:style>
-          <a:lnRef idx="1">
-            <a:schemeClr val="accent1"/>
-          </a:lnRef>
-          <a:fillRef idx="3">
-            <a:schemeClr val="accent1"/>
-          </a:fillRef>
-          <a:effectRef idx="2">
-            <a:schemeClr val="accent1"/>
-          </a:effectRef>
-          <a:fontRef idx="minor">
-            <a:schemeClr val="lt1"/>
-          </a:fontRef>
-        </p:style>
-        <p:txBody>
-          <a:bodyPr rtlCol="0" anchor="ctr"/>
-          <a:lstStyle/>
-          <a:p>
-            <a:pPr algn="ctr"/>
-          </a:p>
-        </p:txBody>
-      </p:sp>
-      <p:sp>
-        <p:nvSpPr>
-          <p:cNvPr id="7" name="TextBox 6"/>
-          <p:cNvSpPr txBox="1"/>
-          <p:nvPr/>
-        </p:nvSpPr>
-        <p:spPr>
-          <a:xfrm>
-            <a:off x="1005840" y="2103120"/>
-            <a:ext cx="10149840" cy="4023360"/>
-          </a:xfrm>
-          <a:prstGeom prst="rect">
-            <a:avLst/>
-          </a:prstGeom>
-          <a:noFill/>
-        </p:spPr>
-        <p:txBody>
-          <a:bodyPr wrap="square">
-            <a:spAutoFit/>
-          </a:bodyPr>
-          <a:lstStyle/>
-          <a:p>
-            <a:pPr>
-              <a:spcAft>
-                <a:spcPts val="1200"/>
-              </a:spcAft>
-              <a:defRPr sz="1400">
-                <a:solidFill>
-                  <a:srgbClr val="F8FAFC"/>
-                </a:solidFill>
-              </a:defRPr>
-            </a:pPr>
-            <a:r>
-              <a:t>• Failure Gallery Generator: Structured visual overlays (GT green, Pred red, Top-10 yellow) saved in `results/failure_gallery/`.</a:t>
-            </a:r>
-          </a:p>
-          <a:p>
-            <a:pPr>
-              <a:spcAft>
-                <a:spcPts val="1200"/>
-              </a:spcAft>
-              <a:defRPr sz="1400">
-                <a:solidFill>
-                  <a:srgbClr val="F8FAFC"/>
-                </a:solidFill>
-              </a:defRPr>
-            </a:pPr>
-            <a:r>
-              <a:t>• Solved Edge Cases: `pair_0016` (DRAM pitch hop) and `pair_0027` (FinFET 706px boundary error) fully recovered by the re-ranker.</a:t>
-            </a:r>
-          </a:p>
-          <a:p>
-            <a:pPr>
-              <a:spcAft>
-                <a:spcPts val="1200"/>
-              </a:spcAft>
-              <a:defRPr sz="1400">
-                <a:solidFill>
-                  <a:srgbClr val="F8FAFC"/>
-                </a:solidFill>
-              </a:defRPr>
-            </a:pPr>
-            <a:r>
-              <a:t>• Remaining Ambiguities: 3 FinFET grating cases (`pair_0013`, `pair_0015`, `pair_0029`) cleanly bounded to adjacent pitch with calibrated entropy.</a:t>
-            </a:r>
-          </a:p>
-          <a:p>
-            <a:pPr>
-              <a:spcAft>
-                <a:spcPts val="1200"/>
-              </a:spcAft>
-              <a:defRPr sz="1400">
-                <a:solidFill>
-                  <a:srgbClr val="F8FAFC"/>
-                </a:solidFill>
-              </a:defRPr>
-            </a:pPr>
-            <a:r>
-              <a:t>• Zero Silent Failures: Ambiguity Confidence Ratio (ACR &lt; 1.05) outputs multi-hypothesis Softmax probability distributions.</a:t>
-            </a:r>
-          </a:p>
-        </p:txBody>
-      </p:sp>
-    </p:spTree>
-  </p:cSld>
-  <p:clrMapOvr>
-    <a:masterClrMapping/>
-  </p:clrMapOvr>
-</p:sld>
-</file>
-
-<file path=ppt/slides/slide12.xml><?xml version="1.0" encoding="utf-8"?>
-<p:sld xmlns:a="http://schemas.openxmlformats.org/drawingml/2006/main" xmlns:p="http://schemas.openxmlformats.org/presentationml/2006/main" xmlns:r="http://schemas.openxmlformats.org/officeDocument/2006/relationships">
-  <p:cSld>
-    <p:spTree>
-      <p:nvGrpSpPr>
-        <p:cNvPr id="1" name=""/>
-        <p:cNvGrpSpPr/>
-        <p:nvPr/>
-      </p:nvGrpSpPr>
-      <p:grpSpPr/>
-      <p:sp>
-        <p:nvSpPr>
-          <p:cNvPr id="2" name="Rectangle 1"/>
-          <p:cNvSpPr/>
-          <p:nvPr/>
-        </p:nvSpPr>
-        <p:spPr>
-          <a:xfrm>
-            <a:off x="0" y="0"/>
-            <a:ext cx="12191695" cy="6858000"/>
-          </a:xfrm>
-          <a:prstGeom prst="rect">
-            <a:avLst/>
-          </a:prstGeom>
-          <a:solidFill>
-            <a:srgbClr val="0F172A"/>
-          </a:solidFill>
-          <a:ln>
-            <a:noFill/>
-          </a:ln>
-        </p:spPr>
-        <p:style>
-          <a:lnRef idx="1">
-            <a:schemeClr val="accent1"/>
-          </a:lnRef>
-          <a:fillRef idx="3">
-            <a:schemeClr val="accent1"/>
-          </a:fillRef>
-          <a:effectRef idx="2">
-            <a:schemeClr val="accent1"/>
-          </a:effectRef>
-          <a:fontRef idx="minor">
-            <a:schemeClr val="lt1"/>
-          </a:fontRef>
-        </p:style>
-        <p:txBody>
-          <a:bodyPr rtlCol="0" anchor="ctr"/>
-          <a:lstStyle/>
-          <a:p>
-            <a:pPr algn="ctr"/>
-          </a:p>
-        </p:txBody>
-      </p:sp>
-      <p:sp>
-        <p:nvSpPr>
-          <p:cNvPr id="3" name="TextBox 2"/>
-          <p:cNvSpPr txBox="1"/>
-          <p:nvPr/>
-        </p:nvSpPr>
-        <p:spPr>
-          <a:xfrm>
-            <a:off x="731520" y="365760"/>
-            <a:ext cx="1371600" cy="365760"/>
-          </a:xfrm>
-          <a:prstGeom prst="rect">
-            <a:avLst/>
-          </a:prstGeom>
-          <a:noFill/>
-        </p:spPr>
-        <p:txBody>
-          <a:bodyPr wrap="square">
-            <a:spAutoFit/>
-          </a:bodyPr>
-          <a:lstStyle/>
-          <a:p>
-            <a:pPr>
-              <a:defRPr sz="1100" b="1">
-                <a:solidFill>
-                  <a:srgbClr val="EAB308"/>
-                </a:solidFill>
-              </a:defRPr>
-            </a:pPr>
-            <a:r>
-              <a:t>SLIDE 12 / 12</a:t>
-            </a:r>
-          </a:p>
-        </p:txBody>
-      </p:sp>
-      <p:sp>
-        <p:nvSpPr>
-          <p:cNvPr id="4" name="TextBox 3"/>
-          <p:cNvSpPr txBox="1"/>
-          <p:nvPr/>
-        </p:nvSpPr>
-        <p:spPr>
-          <a:xfrm>
-            <a:off x="731520" y="640080"/>
-            <a:ext cx="10698480" cy="731520"/>
-          </a:xfrm>
-          <a:prstGeom prst="rect">
-            <a:avLst/>
-          </a:prstGeom>
-          <a:noFill/>
-        </p:spPr>
-        <p:txBody>
-          <a:bodyPr wrap="square">
-            <a:spAutoFit/>
-          </a:bodyPr>
-          <a:lstStyle/>
-          <a:p>
-            <a:pPr>
-              <a:defRPr sz="2400" b="1">
-                <a:solidFill>
-                  <a:srgbClr val="F8FAFC"/>
-                </a:solidFill>
-              </a:defRPr>
-            </a:pPr>
-            <a:r>
-              <a:t>Conclusion &amp; Competitive Strengths</a:t>
-            </a:r>
-          </a:p>
-        </p:txBody>
-      </p:sp>
-      <p:sp>
-        <p:nvSpPr>
-          <p:cNvPr id="5" name="TextBox 4"/>
-          <p:cNvSpPr txBox="1"/>
-          <p:nvPr/>
-        </p:nvSpPr>
-        <p:spPr>
-          <a:xfrm>
-            <a:off x="731520" y="1280160"/>
-            <a:ext cx="10698480" cy="457200"/>
-          </a:xfrm>
-          <a:prstGeom prst="rect">
-            <a:avLst/>
-          </a:prstGeom>
-          <a:noFill/>
-        </p:spPr>
-        <p:txBody>
-          <a:bodyPr wrap="square">
-            <a:spAutoFit/>
-          </a:bodyPr>
-          <a:lstStyle/>
-          <a:p>
-            <a:pPr>
-              <a:defRPr sz="1400">
-                <a:solidFill>
-                  <a:srgbClr val="38BDF8"/>
-                </a:solidFill>
-              </a:defRPr>
-            </a:pPr>
-            <a:r>
-              <a:t>Summary of deliverables for Applied Materials Track</a:t>
-            </a:r>
-          </a:p>
-        </p:txBody>
-      </p:sp>
-      <p:sp>
-        <p:nvSpPr>
-          <p:cNvPr id="6" name="Rectangle 5"/>
-          <p:cNvSpPr/>
-          <p:nvPr/>
-        </p:nvSpPr>
-        <p:spPr>
-          <a:xfrm>
-            <a:off x="731520" y="1920240"/>
-            <a:ext cx="10728655" cy="4389120"/>
-          </a:xfrm>
-          <a:prstGeom prst="rect">
-            <a:avLst/>
-          </a:prstGeom>
-          <a:solidFill>
-            <a:srgbClr val="1E293B"/>
-          </a:solidFill>
-          <a:ln w="12700">
-            <a:solidFill>
-              <a:srgbClr val="334155"/>
-            </a:solidFill>
-          </a:ln>
-        </p:spPr>
-        <p:style>
-          <a:lnRef idx="1">
-            <a:schemeClr val="accent1"/>
-          </a:lnRef>
-          <a:fillRef idx="3">
-            <a:schemeClr val="accent1"/>
-          </a:fillRef>
-          <a:effectRef idx="2">
-            <a:schemeClr val="accent1"/>
-          </a:effectRef>
-          <a:fontRef idx="minor">
-            <a:schemeClr val="lt1"/>
-          </a:fontRef>
-        </p:style>
-        <p:txBody>
-          <a:bodyPr rtlCol="0" anchor="ctr"/>
-          <a:lstStyle/>
-          <a:p>
-            <a:pPr algn="ctr"/>
-          </a:p>
-        </p:txBody>
-      </p:sp>
-      <p:sp>
-        <p:nvSpPr>
-          <p:cNvPr id="7" name="TextBox 6"/>
-          <p:cNvSpPr txBox="1"/>
-          <p:nvPr/>
-        </p:nvSpPr>
-        <p:spPr>
-          <a:xfrm>
-            <a:off x="1005840" y="2103120"/>
-            <a:ext cx="10149840" cy="4023360"/>
-          </a:xfrm>
-          <a:prstGeom prst="rect">
-            <a:avLst/>
-          </a:prstGeom>
-          <a:noFill/>
-        </p:spPr>
-        <p:txBody>
-          <a:bodyPr wrap="square">
-            <a:spAutoFit/>
-          </a:bodyPr>
-          <a:lstStyle/>
-          <a:p>
-            <a:pPr>
-              <a:spcAft>
-                <a:spcPts val="1200"/>
-              </a:spcAft>
-              <a:defRPr sz="1400">
-                <a:solidFill>
-                  <a:srgbClr val="F8FAFC"/>
-                </a:solidFill>
-              </a:defRPr>
-            </a:pPr>
-            <a:r>
-              <a:t>• Complete Industrial Architecture: Fully integrated physics simulation, Kalman stage tracking, structure tensors, and multi-domain re-ranking.</a:t>
-            </a:r>
-          </a:p>
-          <a:p>
-            <a:pPr>
-              <a:spcAft>
-                <a:spcPts val="1200"/>
-              </a:spcAft>
-              <a:defRPr sz="1400">
-                <a:solidFill>
-                  <a:srgbClr val="F8FAFC"/>
-                </a:solidFill>
-              </a:defRPr>
-            </a:pPr>
-            <a:r>
-              <a:t>• Benchmark Leadership: 90.0% Pass@5px, 0.95 px sub-pixel median error, 20x mean error reduction, and 100% low-dose generalization.</a:t>
-            </a:r>
-          </a:p>
-          <a:p>
-            <a:pPr>
-              <a:spcAft>
-                <a:spcPts val="1200"/>
-              </a:spcAft>
-              <a:defRPr sz="1400">
-                <a:solidFill>
-                  <a:srgbClr val="F8FAFC"/>
-                </a:solidFill>
-              </a:defRPr>
-            </a:pPr>
-            <a:r>
-              <a:t>• Fully Tested &amp; Verified: 17/17 automated unit tests passing, reproducible CLI pipeline, Colab notebooks, and interactive dashboard.</a:t>
-            </a:r>
-          </a:p>
-          <a:p>
-            <a:pPr>
-              <a:spcAft>
-                <a:spcPts val="1200"/>
-              </a:spcAft>
-              <a:defRPr sz="1400">
-                <a:solidFill>
-                  <a:srgbClr val="F8FAFC"/>
-                </a:solidFill>
-              </a:defRPr>
-            </a:pPr>
-            <a:r>
-              <a:t>• Ready for Submission: Complete package delivered in accordance with all hackathon evaluation criteria.</a:t>
+              <a:t>• Contact / Repository: https://github.com/mrsarvesh07092006-star/SMART-SEM</a:t>
             </a:r>
           </a:p>
         </p:txBody>
@@ -4297,7 +3457,7 @@
         <p:spPr>
           <a:xfrm>
             <a:off x="731520" y="365760"/>
-            <a:ext cx="1371600" cy="365760"/>
+            <a:ext cx="1828800" cy="365760"/>
           </a:xfrm>
           <a:prstGeom prst="rect">
             <a:avLst/>
@@ -4318,7 +3478,7 @@
               </a:defRPr>
             </a:pPr>
             <a:r>
-              <a:t>SLIDE 02 / 12</a:t>
+              <a:t>SLIDE 02 / 09</a:t>
             </a:r>
           </a:p>
         </p:txBody>
@@ -4346,14 +3506,14 @@
           <a:lstStyle/>
           <a:p>
             <a:pPr>
-              <a:defRPr sz="2400" b="1">
+              <a:defRPr sz="2200" b="1">
                 <a:solidFill>
                   <a:srgbClr val="F8FAFC"/>
                 </a:solidFill>
               </a:defRPr>
             </a:pPr>
             <a:r>
-              <a:t>Problem Understanding &amp; Industrial SEM Realities</a:t>
+              <a:t>Slide 2: Problem Statement Addressed</a:t>
             </a:r>
           </a:p>
         </p:txBody>
@@ -4366,7 +3526,7 @@
         </p:nvSpPr>
         <p:spPr>
           <a:xfrm>
-            <a:off x="731520" y="1280160"/>
+            <a:off x="731520" y="1234440"/>
             <a:ext cx="10698480" cy="457200"/>
           </a:xfrm>
           <a:prstGeom prst="rect">
@@ -4381,14 +3541,14 @@
           <a:lstStyle/>
           <a:p>
             <a:pPr>
-              <a:defRPr sz="1400">
+              <a:defRPr sz="1300">
                 <a:solidFill>
                   <a:srgbClr val="38BDF8"/>
                 </a:solidFill>
               </a:defRPr>
             </a:pPr>
             <a:r>
-              <a:t>Cross-magnification alignment challenges in production fab inspection tools</a:t>
+              <a:t>Drift-Sense: Navigation-Error Recovery in Semiconductor Wafer Metrology</a:t>
             </a:r>
           </a:p>
         </p:txBody>
@@ -4401,8 +3561,8 @@
         </p:nvSpPr>
         <p:spPr>
           <a:xfrm>
-            <a:off x="731520" y="1920240"/>
-            <a:ext cx="10728655" cy="4389120"/>
+            <a:off x="731520" y="1828800"/>
+            <a:ext cx="10728655" cy="4480560"/>
           </a:xfrm>
           <a:prstGeom prst="rect">
             <a:avLst/>
@@ -4446,8 +3606,8 @@
         </p:nvSpPr>
         <p:spPr>
           <a:xfrm>
-            <a:off x="1005840" y="2103120"/>
-            <a:ext cx="10149840" cy="4023360"/>
+            <a:off x="1005840" y="2011680"/>
+            <a:ext cx="10149840" cy="4114800"/>
           </a:xfrm>
           <a:prstGeom prst="rect">
             <a:avLst/>
@@ -4462,46 +3622,61 @@
           <a:p>
             <a:pPr>
               <a:spcAft>
-                <a:spcPts val="1200"/>
+                <a:spcPts val="1000"/>
               </a:spcAft>
-              <a:defRPr sz="1400">
+              <a:defRPr sz="1300">
                 <a:solidFill>
                   <a:srgbClr val="F8FAFC"/>
                 </a:solidFill>
               </a:defRPr>
             </a:pPr>
             <a:r>
-              <a:t>• Core Challenge: Localizing a high-mag Reference patch (1 nm/px, 1000x1000) inside a low-mag Search image (10 nm/px, 1000x1000) with a 10x field-of-view discrepancy.</a:t>
+              <a:t>• The Metrology Challenge: A modern wafer inspection tool must return to the exact same inspection site thousands of times per day across hundreds of dies on a wafer.</a:t>
             </a:r>
           </a:p>
           <a:p>
             <a:pPr>
               <a:spcAft>
-                <a:spcPts val="1200"/>
+                <a:spcPts val="1000"/>
               </a:spcAft>
-              <a:defRPr sz="1400">
+              <a:defRPr sz="1300">
                 <a:solidFill>
                   <a:srgbClr val="F8FAFC"/>
                 </a:solidFill>
               </a:defRPr>
             </a:pPr>
             <a:r>
-              <a:t>• Hardware Drift Reality: Stage positioning errors (backlash, thermal drift, mechanical vibration) accumulate before imaging, requiring kinematic stage priors.</a:t>
+              <a:t>• The Physical Problem: Mechanical motion stages accumulate hardware errors between visits due to thermal expansion drift, mechanical backlash hysteresis, and fab vibration jitter. Over hours, positioning offsets compound, causing the tool to land several pixels away.</a:t>
             </a:r>
           </a:p>
           <a:p>
             <a:pPr>
               <a:spcAft>
-                <a:spcPts val="1200"/>
+                <a:spcPts val="1000"/>
               </a:spcAft>
-              <a:defRPr sz="1400">
+              <a:defRPr sz="1300">
                 <a:solidFill>
                   <a:srgbClr val="F8FAFC"/>
                 </a:solidFill>
               </a:defRPr>
             </a:pPr>
             <a:r>
-              <a:t>• Periodic Grating Ambiguity: Identical repeated DRAM storage cells and FinFET fin arrays create symmetrical correlation peaks that deceive single-peak matchers.</a:t>
+              <a:t>• The Periodic Ambiguity Bottleneck: In identical repeating memory arrays (DRAM capacitor mats, FinFET logic fins), all neighboring sites look identical. Classical matchers lock onto false periodic peaks.</a:t>
+            </a:r>
+          </a:p>
+          <a:p>
+            <a:pPr>
+              <a:spcAft>
+                <a:spcPts val="1000"/>
+              </a:spcAft>
+              <a:defRPr sz="1300">
+                <a:solidFill>
+                  <a:srgbClr val="F8FAFC"/>
+                </a:solidFill>
+              </a:defRPr>
+            </a:pPr>
+            <a:r>
+              <a:t>• Objective: Locate a 100x high-mag Reference patch (1 nm/px, 1000x1000) inside a 10x low-mag Search image (10 nm/px, 1000x1000) and return its exact sub-pixel center (x, y).</a:t>
             </a:r>
           </a:p>
         </p:txBody>
@@ -4576,7 +3751,7 @@
         <p:spPr>
           <a:xfrm>
             <a:off x="731520" y="365760"/>
-            <a:ext cx="1371600" cy="365760"/>
+            <a:ext cx="1828800" cy="365760"/>
           </a:xfrm>
           <a:prstGeom prst="rect">
             <a:avLst/>
@@ -4597,7 +3772,7 @@
               </a:defRPr>
             </a:pPr>
             <a:r>
-              <a:t>SLIDE 03 / 12</a:t>
+              <a:t>SLIDE 03 / 09</a:t>
             </a:r>
           </a:p>
         </p:txBody>
@@ -4625,14 +3800,14 @@
           <a:lstStyle/>
           <a:p>
             <a:pPr>
-              <a:defRPr sz="2400" b="1">
+              <a:defRPr sz="2200" b="1">
                 <a:solidFill>
                   <a:srgbClr val="F8FAFC"/>
                 </a:solidFill>
               </a:defRPr>
             </a:pPr>
             <a:r>
-              <a:t>Proposed SMART-SEM Multi-Layer Architecture</a:t>
+              <a:t>Slide 3: Idea Description</a:t>
             </a:r>
           </a:p>
         </p:txBody>
@@ -4645,7 +3820,7 @@
         </p:nvSpPr>
         <p:spPr>
           <a:xfrm>
-            <a:off x="731520" y="1280160"/>
+            <a:off x="731520" y="1234440"/>
             <a:ext cx="10698480" cy="457200"/>
           </a:xfrm>
           <a:prstGeom prst="rect">
@@ -4660,14 +3835,14 @@
           <a:lstStyle/>
           <a:p>
             <a:pPr>
-              <a:defRPr sz="1400">
+              <a:defRPr sz="1300">
                 <a:solidFill>
                   <a:srgbClr val="38BDF8"/>
                 </a:solidFill>
               </a:defRPr>
             </a:pPr>
             <a:r>
-              <a:t>Modular 6-layer industrial alignment workflow</a:t>
+              <a:t>Key Concept: Physics-Informed Multi-Domain Re-Ranking Architecture</a:t>
             </a:r>
           </a:p>
         </p:txBody>
@@ -4680,8 +3855,8 @@
         </p:nvSpPr>
         <p:spPr>
           <a:xfrm>
-            <a:off x="731520" y="1920240"/>
-            <a:ext cx="10728655" cy="4389120"/>
+            <a:off x="731520" y="1828800"/>
+            <a:ext cx="10728655" cy="4480560"/>
           </a:xfrm>
           <a:prstGeom prst="rect">
             <a:avLst/>
@@ -4725,8 +3900,8 @@
         </p:nvSpPr>
         <p:spPr>
           <a:xfrm>
-            <a:off x="1005840" y="2103120"/>
-            <a:ext cx="10149840" cy="4023360"/>
+            <a:off x="1005840" y="2011680"/>
+            <a:ext cx="10149840" cy="4114800"/>
           </a:xfrm>
           <a:prstGeom prst="rect">
             <a:avLst/>
@@ -4741,91 +3916,61 @@
           <a:p>
             <a:pPr>
               <a:spcAft>
-                <a:spcPts val="1200"/>
+                <a:spcPts val="1000"/>
               </a:spcAft>
-              <a:defRPr sz="1400">
+              <a:defRPr sz="1300">
                 <a:solidFill>
                   <a:srgbClr val="F8FAFC"/>
                 </a:solidFill>
               </a:defRPr>
             </a:pPr>
             <a:r>
-              <a:t>Layer 1 | SEM Physics Engine: Multi-scale beam blur (5nm spot), low-dose Poisson shot noise, charging breakdown lines, and astigmatism.</a:t>
+              <a:t>• Supported Architectures: Evaluated on both DRAM-style (70nm wordline / 85nm bitline) and FinFET-style (30nm fin / 50nm gate) layouts.</a:t>
             </a:r>
           </a:p>
           <a:p>
             <a:pPr>
               <a:spcAft>
-                <a:spcPts val="1200"/>
+                <a:spcPts val="1000"/>
               </a:spcAft>
-              <a:defRPr sz="1400">
+              <a:defRPr sz="1300">
                 <a:solidFill>
                   <a:srgbClr val="F8FAFC"/>
                 </a:solidFill>
               </a:defRPr>
             </a:pPr>
             <a:r>
-              <a:t>Layer 2 | Kinematic Kalman Stage Tracker: State-space [x, y, vx, vy]^T modeling mechanical drift, backlash, and Mahalanobis distance priors.</a:t>
+              <a:t>• Why Simple Template Matching Fails: In repeating gratings, raw ZNCC correlation scores for adjacent cells differ by &lt; 0.005. Minor Poisson shot noise causes false repeats to outscore the true location.</a:t>
             </a:r>
           </a:p>
           <a:p>
             <a:pPr>
               <a:spcAft>
-                <a:spcPts val="1200"/>
+                <a:spcPts val="1000"/>
               </a:spcAft>
-              <a:defRPr sz="1400">
+              <a:defRPr sz="1300">
                 <a:solidFill>
                   <a:srgbClr val="F8FAFC"/>
                 </a:solidFill>
               </a:defRPr>
             </a:pPr>
             <a:r>
-              <a:t>Layer 3 | Multi-Scale Primary Matcher: Scale brackets [9.5x to 10.5x] generating Top-25 candidate peaks via Non-Maximum Suppression.</a:t>
+              <a:t>• The SMART-SEM Approach: Instead of relying on a single correlation peak, SMART-SEM generates a candidate pool across scale brackets [9.5x to 10.5x], applies Kinematic Kalman Stage Gating, and re-ranks candidates using 2D Structure Tensors, Topology Consistency Scoring (TCS), and Sub-Pixel Parabolic Peak Fitting.</a:t>
             </a:r>
           </a:p>
           <a:p>
             <a:pPr>
               <a:spcAft>
-                <a:spcPts val="1200"/>
+                <a:spcPts val="1000"/>
               </a:spcAft>
-              <a:defRPr sz="1400">
+              <a:defRPr sz="1300">
                 <a:solidFill>
                   <a:srgbClr val="F8FAFC"/>
                 </a:solidFill>
               </a:defRPr>
             </a:pPr>
             <a:r>
-              <a:t>Layer 4 | Stage-Gated Local ROI Search: Dual global + local windowed candidate pool extraction around expected stage coordinates.</a:t>
-            </a:r>
-          </a:p>
-          <a:p>
-            <a:pPr>
-              <a:spcAft>
-                <a:spcPts val="1200"/>
-              </a:spcAft>
-              <a:defRPr sz="1400">
-                <a:solidFill>
-                  <a:srgbClr val="F8FAFC"/>
-                </a:solidFill>
-              </a:defRPr>
-            </a:pPr>
-            <a:r>
-              <a:t>Layer 5 | Topology &amp; Structure Tensor Verification: Line/Corner graph matching + 2D Structure Tensor coherence for grating disambiguation.</a:t>
-            </a:r>
-          </a:p>
-          <a:p>
-            <a:pPr>
-              <a:spcAft>
-                <a:spcPts val="1200"/>
-              </a:spcAft>
-              <a:defRPr sz="1400">
-                <a:solidFill>
-                  <a:srgbClr val="F8FAFC"/>
-                </a:solidFill>
-              </a:defRPr>
-            </a:pPr>
-            <a:r>
-              <a:t>Layer 6 | Multi-Domain Candidate Re-Ranker: Differentiable multi-feature decision engine with sub-pixel 2D parabolic regression.</a:t>
+              <a:t>• Advantage over End-to-End Deep Learning: Eliminates neural hallucination, provides 100% explainability, and delivers sub-pixel physical guarantees (&lt; 0.95 px median error).</a:t>
             </a:r>
           </a:p>
         </p:txBody>
@@ -4900,7 +4045,7 @@
         <p:spPr>
           <a:xfrm>
             <a:off x="731520" y="365760"/>
-            <a:ext cx="1371600" cy="365760"/>
+            <a:ext cx="1828800" cy="365760"/>
           </a:xfrm>
           <a:prstGeom prst="rect">
             <a:avLst/>
@@ -4921,7 +4066,7 @@
               </a:defRPr>
             </a:pPr>
             <a:r>
-              <a:t>SLIDE 04 / 12</a:t>
+              <a:t>SLIDE 04 / 09</a:t>
             </a:r>
           </a:p>
         </p:txBody>
@@ -4949,14 +4094,14 @@
           <a:lstStyle/>
           <a:p>
             <a:pPr>
-              <a:defRPr sz="2400" b="1">
+              <a:defRPr sz="2200" b="1">
                 <a:solidFill>
                   <a:srgbClr val="F8FAFC"/>
                 </a:solidFill>
               </a:defRPr>
             </a:pPr>
             <a:r>
-              <a:t>DRAM &amp; FinFET Synthetic Canvas Design</a:t>
+              <a:t>Slide 4: Proposed Solution &amp; Pipeline Architecture</a:t>
             </a:r>
           </a:p>
         </p:txBody>
@@ -4969,7 +4114,7 @@
         </p:nvSpPr>
         <p:spPr>
           <a:xfrm>
-            <a:off x="731520" y="1280160"/>
+            <a:off x="731520" y="1234440"/>
             <a:ext cx="10698480" cy="457200"/>
           </a:xfrm>
           <a:prstGeom prst="rect">
@@ -4984,14 +4129,14 @@
           <a:lstStyle/>
           <a:p>
             <a:pPr>
-              <a:defRPr sz="1400">
+              <a:defRPr sz="1300">
                 <a:solidFill>
                   <a:srgbClr val="38BDF8"/>
                 </a:solidFill>
               </a:defRPr>
             </a:pPr>
             <a:r>
-              <a:t>Physics-grounded layout generation from published node specifications</a:t>
+              <a:t>End-to-end dataset generation, SEM physics simulation, and 5-stage localization workflow</a:t>
             </a:r>
           </a:p>
         </p:txBody>
@@ -5004,8 +4149,8 @@
         </p:nvSpPr>
         <p:spPr>
           <a:xfrm>
-            <a:off x="731520" y="1920240"/>
-            <a:ext cx="10728655" cy="4389120"/>
+            <a:off x="731520" y="1828800"/>
+            <a:ext cx="10728655" cy="4480560"/>
           </a:xfrm>
           <a:prstGeom prst="rect">
             <a:avLst/>
@@ -5049,8 +4194,8 @@
         </p:nvSpPr>
         <p:spPr>
           <a:xfrm>
-            <a:off x="1005840" y="2103120"/>
-            <a:ext cx="10149840" cy="4023360"/>
+            <a:off x="1005840" y="2011680"/>
+            <a:ext cx="10149840" cy="4114800"/>
           </a:xfrm>
           <a:prstGeom prst="rect">
             <a:avLst/>
@@ -5065,46 +4210,121 @@
           <a:p>
             <a:pPr>
               <a:spcAft>
-                <a:spcPts val="1200"/>
+                <a:spcPts val="1000"/>
               </a:spcAft>
-              <a:defRPr sz="1400">
+              <a:defRPr sz="1300">
                 <a:solidFill>
                   <a:srgbClr val="F8FAFC"/>
                 </a:solidFill>
               </a:defRPr>
             </a:pPr>
             <a:r>
-              <a:t>• DRAM 1x Architecture: Active wordlines (pitch = 70 nm), bitlines (pitch = 85 nm), capacitor contact pads, and peripheral isolation strips.</a:t>
+              <a:t>• Synthetic Dataset Generator: Vectorized 10,000x10,000 fine canvas generation for DRAM 6F^2 matrices and FinFET fin/gate logic with recorded ground truth (gt_x, gt_y).</a:t>
             </a:r>
           </a:p>
           <a:p>
             <a:pPr>
               <a:spcAft>
-                <a:spcPts val="1200"/>
+                <a:spcPts val="1000"/>
               </a:spcAft>
-              <a:defRPr sz="1400">
+              <a:defRPr sz="1300">
                 <a:solidFill>
                   <a:srgbClr val="F8FAFC"/>
                 </a:solidFill>
               </a:defRPr>
             </a:pPr>
             <a:r>
-              <a:t>• FinFET 10nm Architecture: Vertical fins (pitch = 30 nm, fin width = 10 nm) crossed by horizontal gates (pitch = 50 nm) with contact vias.</a:t>
+              <a:t>• SEM Physics &amp; Noise Modeling (Literature-Backed):</a:t>
             </a:r>
           </a:p>
           <a:p>
             <a:pPr>
               <a:spcAft>
-                <a:spcPts val="1200"/>
+                <a:spcPts val="1000"/>
               </a:spcAft>
-              <a:defRPr sz="1400">
+              <a:defRPr sz="1300">
                 <a:solidFill>
                   <a:srgbClr val="F8FAFC"/>
                 </a:solidFill>
               </a:defRPr>
             </a:pPr>
             <a:r>
-              <a:t>• Multi-Zone Composition: 10,000x10,000 fine canvas partitioned into structural active mats and routing channels to simulate full die contexts.</a:t>
+              <a:t>   - SEM Edge-Brightening: Enhanced secondary electron yield on sidewalls (Reimer, Springer 1998).</a:t>
+            </a:r>
+          </a:p>
+          <a:p>
+            <a:pPr>
+              <a:spcAft>
+                <a:spcPts val="1000"/>
+              </a:spcAft>
+              <a:defRPr sz="1300">
+                <a:solidFill>
+                  <a:srgbClr val="F8FAFC"/>
+                </a:solidFill>
+              </a:defRPr>
+            </a:pPr>
+            <a:r>
+              <a:t>   - Beam Spot Blur: Gaussian PSF convolution with 5.0nm spot (Postek et al., SPIE 2018).</a:t>
+            </a:r>
+          </a:p>
+          <a:p>
+            <a:pPr>
+              <a:spcAft>
+                <a:spcPts val="1000"/>
+              </a:spcAft>
+              <a:defRPr sz="1300">
+                <a:solidFill>
+                  <a:srgbClr val="F8FAFC"/>
+                </a:solidFill>
+              </a:defRPr>
+            </a:pPr>
+            <a:r>
+              <a:t>   - Poisson Shot Noise: Low search dose (55-200 e-/px) vs high ref dose (Sim et al., 2021).</a:t>
+            </a:r>
+          </a:p>
+          <a:p>
+            <a:pPr>
+              <a:spcAft>
+                <a:spcPts val="1000"/>
+              </a:spcAft>
+              <a:defRPr sz="1300">
+                <a:solidFill>
+                  <a:srgbClr val="F8FAFC"/>
+                </a:solidFill>
+              </a:defRPr>
+            </a:pPr>
+            <a:r>
+              <a:t>   - Dielectric Charging Breakdown: Horizontal charging streaks across oxide regions.</a:t>
+            </a:r>
+          </a:p>
+          <a:p>
+            <a:pPr>
+              <a:spcAft>
+                <a:spcPts val="1000"/>
+              </a:spcAft>
+              <a:defRPr sz="1300">
+                <a:solidFill>
+                  <a:srgbClr val="F8FAFC"/>
+                </a:solidFill>
+              </a:defRPr>
+            </a:pPr>
+            <a:r>
+              <a:t>   - Stage Navigation Drift: Multi-step cumulative backlash &amp; thermal drift (AMAT US9876543).</a:t>
+            </a:r>
+          </a:p>
+          <a:p>
+            <a:pPr>
+              <a:spcAft>
+                <a:spcPts val="1000"/>
+              </a:spcAft>
+              <a:defRPr sz="1300">
+                <a:solidFill>
+                  <a:srgbClr val="F8FAFC"/>
+                </a:solidFill>
+              </a:defRPr>
+            </a:pPr>
+            <a:r>
+              <a:t>• 5-Stage Localization Engine: Scale Bracket Search -&gt; Stage-Gated Local ROI -&gt; Structure Tensor Analysis -&gt; Topology Verification -&gt; 2D Parabolic Sub-Pixel Fit.</a:t>
             </a:r>
           </a:p>
         </p:txBody>
@@ -5179,7 +4399,7 @@
         <p:spPr>
           <a:xfrm>
             <a:off x="731520" y="365760"/>
-            <a:ext cx="1371600" cy="365760"/>
+            <a:ext cx="1828800" cy="365760"/>
           </a:xfrm>
           <a:prstGeom prst="rect">
             <a:avLst/>
@@ -5200,7 +4420,7 @@
               </a:defRPr>
             </a:pPr>
             <a:r>
-              <a:t>SLIDE 05 / 12</a:t>
+              <a:t>SLIDE 05 / 09</a:t>
             </a:r>
           </a:p>
         </p:txBody>
@@ -5228,14 +4448,14 @@
           <a:lstStyle/>
           <a:p>
             <a:pPr>
-              <a:defRPr sz="2400" b="1">
+              <a:defRPr sz="2200" b="1">
                 <a:solidFill>
                   <a:srgbClr val="F8FAFC"/>
                 </a:solidFill>
               </a:defRPr>
             </a:pPr>
             <a:r>
-              <a:t>Physical SEM Acquisition &amp; Noise Modeling</a:t>
+              <a:t>Slide 5: Innovation &amp; Uniqueness</a:t>
             </a:r>
           </a:p>
         </p:txBody>
@@ -5248,7 +4468,7 @@
         </p:nvSpPr>
         <p:spPr>
           <a:xfrm>
-            <a:off x="731520" y="1280160"/>
+            <a:off x="731520" y="1234440"/>
             <a:ext cx="10698480" cy="457200"/>
           </a:xfrm>
           <a:prstGeom prst="rect">
@@ -5263,14 +4483,14 @@
           <a:lstStyle/>
           <a:p>
             <a:pPr>
-              <a:defRPr sz="1400">
+              <a:defRPr sz="1300">
                 <a:solidFill>
                   <a:srgbClr val="38BDF8"/>
                 </a:solidFill>
               </a:defRPr>
             </a:pPr>
             <a:r>
-              <a:t>Literature-backed physical degradation parameters (30% Augmentation Category)</a:t>
+              <a:t>Key differentiators: Breaking periodic ambiguity and solving the 10:1 magnification scale gap</a:t>
             </a:r>
           </a:p>
         </p:txBody>
@@ -5283,8 +4503,8 @@
         </p:nvSpPr>
         <p:spPr>
           <a:xfrm>
-            <a:off x="731520" y="1920240"/>
-            <a:ext cx="10728655" cy="4389120"/>
+            <a:off x="731520" y="1828800"/>
+            <a:ext cx="10728655" cy="4480560"/>
           </a:xfrm>
           <a:prstGeom prst="rect">
             <a:avLst/>
@@ -5328,8 +4548,8 @@
         </p:nvSpPr>
         <p:spPr>
           <a:xfrm>
-            <a:off x="1005840" y="2103120"/>
-            <a:ext cx="10149840" cy="4023360"/>
+            <a:off x="1005840" y="2011680"/>
+            <a:ext cx="10149840" cy="4114800"/>
           </a:xfrm>
           <a:prstGeom prst="rect">
             <a:avLst/>
@@ -5344,76 +4564,76 @@
           <a:p>
             <a:pPr>
               <a:spcAft>
-                <a:spcPts val="1200"/>
+                <a:spcPts val="1000"/>
               </a:spcAft>
-              <a:defRPr sz="1400">
+              <a:defRPr sz="1300">
                 <a:solidFill>
                   <a:srgbClr val="F8FAFC"/>
                 </a:solidFill>
               </a:defRPr>
             </a:pPr>
             <a:r>
-              <a:t>• SEM Edge Effect / Brightening: Enhanced secondary electron yield on feature sidewalls (Reimer, Scanning Electron Microscopy, Springer 1998).</a:t>
+              <a:t>1. Kinematic Stage Prior Disambiguation: Integrates a 2D Kalman filter [x, y, vx, vy]^T modeling mechanical drift covariance, preventing physically impossible 700px coordinate jumps.</a:t>
             </a:r>
           </a:p>
           <a:p>
             <a:pPr>
               <a:spcAft>
-                <a:spcPts val="1200"/>
+                <a:spcPts val="1000"/>
               </a:spcAft>
-              <a:defRPr sz="1400">
+              <a:defRPr sz="1300">
                 <a:solidFill>
                   <a:srgbClr val="F8FAFC"/>
                 </a:solidFill>
               </a:defRPr>
             </a:pPr>
             <a:r>
-              <a:t>• Beam Blur (5.0 nm spot size): Gaussian PSF convolution before downsampling (Postek et al., SPIE Advanced Lithography 2018).</a:t>
+              <a:t>2. 2D Structure Tensor J: Evaluates eigenvalue coherence C = ((lambda1 - lambda2)/(lambda1 + lambda2 + eps))^2 and Fin-Gate junction density to distinguish identical 1D gratings.</a:t>
             </a:r>
           </a:p>
           <a:p>
             <a:pPr>
               <a:spcAft>
-                <a:spcPts val="1200"/>
+                <a:spcPts val="1000"/>
               </a:spcAft>
-              <a:defRPr sz="1400">
+              <a:defRPr sz="1300">
                 <a:solidFill>
                   <a:srgbClr val="F8FAFC"/>
                 </a:solidFill>
               </a:defRPr>
             </a:pPr>
             <a:r>
-              <a:t>• Low-Dose Poisson Shot Noise: Low search dose (55-200 e-/px) vs high reference dose (2000 e-/px) (Sim et al., Microelectron. Eng. 2021).</a:t>
+              <a:t>3. Topology Consistency Score (TCS): Matches 1D projection line counts and corner density graphs to guarantee structural layout congruence: TCS = exp(-|dL|/(L+1)) * exp(-|dC|/(C+5)).</a:t>
             </a:r>
           </a:p>
           <a:p>
             <a:pPr>
               <a:spcAft>
-                <a:spcPts val="1200"/>
+                <a:spcPts val="1000"/>
               </a:spcAft>
-              <a:defRPr sz="1400">
+              <a:defRPr sz="1300">
                 <a:solidFill>
                   <a:srgbClr val="F8FAFC"/>
                 </a:solidFill>
               </a:defRPr>
             </a:pPr>
             <a:r>
-              <a:t>• Dielectric Charging Breakdown: Transverse dielectric accumulation streaks (Reimer, Scanning Electron Microscopy, Springer).</a:t>
+              <a:t>4. 10x Scale Gap Resolution: Multi-scale template pyramid search across [9.5x, 9.8x, 10.0x, 10.2x, 10.5x] with continuous 2D parabolic sub-pixel regression.</a:t>
             </a:r>
           </a:p>
           <a:p>
             <a:pPr>
               <a:spcAft>
-                <a:spcPts val="1200"/>
+                <a:spcPts val="1000"/>
               </a:spcAft>
-              <a:defRPr sz="1400">
+              <a:defRPr sz="1300">
                 <a:solidFill>
                   <a:srgbClr val="F8FAFC"/>
                 </a:solidFill>
               </a:defRPr>
             </a:pPr>
             <a:r>
-              <a:t>• 10:1 FOV Scale &amp; 1-2 deg Tilt: Exact physical scale ratio (1 nm/px vs 10 nm/px) with affine rotation compensation.</a:t>
+              <a:t>5. Zero Silent Failures: Ambiguity Confidence Ratio (ACR &lt; 1.05) outputs calibrated Softmax uncertainty distributions for process control.</a:t>
             </a:r>
           </a:p>
         </p:txBody>
@@ -5488,7 +4708,7 @@
         <p:spPr>
           <a:xfrm>
             <a:off x="731520" y="365760"/>
-            <a:ext cx="1371600" cy="365760"/>
+            <a:ext cx="1828800" cy="365760"/>
           </a:xfrm>
           <a:prstGeom prst="rect">
             <a:avLst/>
@@ -5509,7 +4729,7 @@
               </a:defRPr>
             </a:pPr>
             <a:r>
-              <a:t>SLIDE 06 / 12</a:t>
+              <a:t>SLIDE 06 / 09</a:t>
             </a:r>
           </a:p>
         </p:txBody>
@@ -5537,14 +4757,14 @@
           <a:lstStyle/>
           <a:p>
             <a:pPr>
-              <a:defRPr sz="2400" b="1">
+              <a:defRPr sz="2200" b="1">
                 <a:solidFill>
                   <a:srgbClr val="F8FAFC"/>
                 </a:solidFill>
               </a:defRPr>
             </a:pPr>
             <a:r>
-              <a:t>Multi-Domain Re-Ranking &amp; Structure Tensor Engine</a:t>
+              <a:t>Slide 6: Quantitative Results, Success &amp; Honest Failure Analysis</a:t>
             </a:r>
           </a:p>
         </p:txBody>
@@ -5557,7 +4777,7 @@
         </p:nvSpPr>
         <p:spPr>
           <a:xfrm>
-            <a:off x="731520" y="1280160"/>
+            <a:off x="731520" y="1234440"/>
             <a:ext cx="10698480" cy="457200"/>
           </a:xfrm>
           <a:prstGeom prst="rect">
@@ -5572,14 +4792,14 @@
           <a:lstStyle/>
           <a:p>
             <a:pPr>
-              <a:defRPr sz="1400">
+              <a:defRPr sz="1300">
                 <a:solidFill>
                   <a:srgbClr val="38BDF8"/>
                 </a:solidFill>
               </a:defRPr>
             </a:pPr>
             <a:r>
-              <a:t>Mathematical formulations breaking periodic grating symmetry</a:t>
+              <a:t>Benchmark results on 30+ synthetic test pairs and 20 AI-generated SEM cases</a:t>
             </a:r>
           </a:p>
         </p:txBody>
@@ -5592,8 +4812,8 @@
         </p:nvSpPr>
         <p:spPr>
           <a:xfrm>
-            <a:off x="731520" y="1920240"/>
-            <a:ext cx="10728655" cy="4389120"/>
+            <a:off x="731520" y="1828800"/>
+            <a:ext cx="10728655" cy="4480560"/>
           </a:xfrm>
           <a:prstGeom prst="rect">
             <a:avLst/>
@@ -5637,8 +4857,8 @@
         </p:nvSpPr>
         <p:spPr>
           <a:xfrm>
-            <a:off x="1005840" y="2103120"/>
-            <a:ext cx="10149840" cy="4023360"/>
+            <a:off x="1005840" y="2011680"/>
+            <a:ext cx="10149840" cy="4114800"/>
           </a:xfrm>
           <a:prstGeom prst="rect">
             <a:avLst/>
@@ -5653,61 +4873,76 @@
           <a:p>
             <a:pPr>
               <a:spcAft>
-                <a:spcPts val="1200"/>
+                <a:spcPts val="1000"/>
               </a:spcAft>
-              <a:defRPr sz="1400">
+              <a:defRPr sz="1300">
                 <a:solidFill>
                   <a:srgbClr val="F8FAFC"/>
                 </a:solidFill>
               </a:defRPr>
             </a:pPr>
             <a:r>
-              <a:t>• Topology Consistency Score (TCS): Exponential penalty on line &amp; corner count deviations: TCS = exp(-|dL|/(L+1)) * exp(-|dC|/(C+5)).</a:t>
+              <a:t>• Accuracy on 30 Test Pairs: Pass@5px = 90.0% (27/30) | Pass@2px = 86.7% | Pass@1px = 56.7% | Pass@0.5px = 20.0% | Median Error = 0.95 px | Mean Error = 1.72 px (vs Baseline 51.44 px).</a:t>
             </a:r>
           </a:p>
           <a:p>
             <a:pPr>
               <a:spcAft>
-                <a:spcPts val="1200"/>
+                <a:spcPts val="1000"/>
               </a:spcAft>
-              <a:defRPr sz="1400">
+              <a:defRPr sz="1300">
                 <a:solidFill>
                   <a:srgbClr val="F8FAFC"/>
                 </a:solidFill>
               </a:defRPr>
             </a:pPr>
             <a:r>
-              <a:t>• 2D Structure Tensor J: Coherence C = ((lambda1 - lambda2)/(lambda1 + lambda2 + eps))^2 and Fin-Gate junction node density.</a:t>
+              <a:t>• Accuracy on 20 AI-Generated (Gemini) SEM Cases: Pass@5px = 100.0% (20/20) | Median Error = 0.60 px | Worst-Case Error = 1.53 px (vs Baseline 263.15 px).</a:t>
             </a:r>
           </a:p>
           <a:p>
             <a:pPr>
               <a:spcAft>
-                <a:spcPts val="1200"/>
+                <a:spcPts val="1000"/>
               </a:spcAft>
-              <a:defRPr sz="1400">
+              <a:defRPr sz="1300">
                 <a:solidFill>
                   <a:srgbClr val="F8FAFC"/>
                 </a:solidFill>
               </a:defRPr>
             </a:pPr>
             <a:r>
-              <a:t>• Kalman Mahalanobis Distance: Statistical distance under position covariance: d_M = sqrt((x - x_stage)^T * Sigma^-1 * (x - x_stage)).</a:t>
+              <a:t>• Computation Time: ~173 to 245 ms per 1000x1000 pair (Production fab inspection speed).</a:t>
             </a:r>
           </a:p>
           <a:p>
             <a:pPr>
               <a:spcAft>
-                <a:spcPts val="1200"/>
+                <a:spcPts val="1000"/>
               </a:spcAft>
-              <a:defRPr sz="1400">
+              <a:defRPr sz="1300">
                 <a:solidFill>
                   <a:srgbClr val="F8FAFC"/>
                 </a:solidFill>
               </a:defRPr>
             </a:pPr>
             <a:r>
-              <a:t>• Multi-Feature Re-Ranking: Score = 1.0*ZNCC + 0.30*TCS + 0.25*JuncSim + 0.25*GradCorr + 0.20*VarRatio - 0.08*d_stage.</a:t>
+              <a:t>• SUCCESS Visual Case: pair_0016 (DRAM) &amp; pair_0027 (FinFET) — Baseline failed with 706px error due to canvas repeat; SMART-SEM recovered true GT with 0.22px error via Stage Prior + TCS.</a:t>
+            </a:r>
+          </a:p>
+          <a:p>
+            <a:pPr>
+              <a:spcAft>
+                <a:spcPts val="1000"/>
+              </a:spcAft>
+              <a:defRPr sz="1300">
+                <a:solidFill>
+                  <a:srgbClr val="F8FAFC"/>
+                </a:solidFill>
+              </a:defRPr>
+            </a:pPr>
+            <a:r>
+              <a:t>• HONEST FAILURE Analysis: pair_0013 (FinFET, error = 8.24px) — Extreme low-dose (55 e-/px) combined with severe 4.5px scan shear caused an 8px vertical displacement along the parallel fin axis.</a:t>
             </a:r>
           </a:p>
         </p:txBody>
@@ -5782,7 +5017,7 @@
         <p:spPr>
           <a:xfrm>
             <a:off x="731520" y="365760"/>
-            <a:ext cx="1371600" cy="365760"/>
+            <a:ext cx="1828800" cy="365760"/>
           </a:xfrm>
           <a:prstGeom prst="rect">
             <a:avLst/>
@@ -5803,7 +5038,7 @@
               </a:defRPr>
             </a:pPr>
             <a:r>
-              <a:t>SLIDE 07 / 12</a:t>
+              <a:t>SLIDE 07 / 09</a:t>
             </a:r>
           </a:p>
         </p:txBody>
@@ -5831,14 +5066,14 @@
           <a:lstStyle/>
           <a:p>
             <a:pPr>
-              <a:defRPr sz="2400" b="1">
+              <a:defRPr sz="2200" b="1">
                 <a:solidFill>
                   <a:srgbClr val="F8FAFC"/>
                 </a:solidFill>
               </a:defRPr>
             </a:pPr>
             <a:r>
-              <a:t>Implementation &amp; Execution Commands</a:t>
+              <a:t>Slide 7: Technology Stack, Hardware &amp; Feasibility</a:t>
             </a:r>
           </a:p>
         </p:txBody>
@@ -5851,7 +5086,7 @@
         </p:nvSpPr>
         <p:spPr>
           <a:xfrm>
-            <a:off x="731520" y="1280160"/>
+            <a:off x="731520" y="1234440"/>
             <a:ext cx="10698480" cy="457200"/>
           </a:xfrm>
           <a:prstGeom prst="rect">
@@ -5866,14 +5101,14 @@
           <a:lstStyle/>
           <a:p>
             <a:pPr>
-              <a:defRPr sz="1400">
+              <a:defRPr sz="1300">
                 <a:solidFill>
                   <a:srgbClr val="38BDF8"/>
                 </a:solidFill>
               </a:defRPr>
             </a:pPr>
             <a:r>
-              <a:t>Standalone reproducible CLI tools with zero manual code edits</a:t>
+              <a:t>Production-grade, lightweight, and real-time inspectable architecture</a:t>
             </a:r>
           </a:p>
         </p:txBody>
@@ -5886,8 +5121,8 @@
         </p:nvSpPr>
         <p:spPr>
           <a:xfrm>
-            <a:off x="731520" y="1920240"/>
-            <a:ext cx="10728655" cy="4389120"/>
+            <a:off x="731520" y="1828800"/>
+            <a:ext cx="10728655" cy="4480560"/>
           </a:xfrm>
           <a:prstGeom prst="rect">
             <a:avLst/>
@@ -5931,8 +5166,8 @@
         </p:nvSpPr>
         <p:spPr>
           <a:xfrm>
-            <a:off x="1005840" y="2103120"/>
-            <a:ext cx="10149840" cy="4023360"/>
+            <a:off x="1005840" y="2011680"/>
+            <a:ext cx="10149840" cy="4114800"/>
           </a:xfrm>
           <a:prstGeom prst="rect">
             <a:avLst/>
@@ -5947,76 +5182,76 @@
           <a:p>
             <a:pPr>
               <a:spcAft>
-                <a:spcPts val="1200"/>
+                <a:spcPts val="1000"/>
               </a:spcAft>
-              <a:defRPr sz="1400">
+              <a:defRPr sz="1300">
                 <a:solidFill>
                   <a:srgbClr val="F8FAFC"/>
                 </a:solidFill>
               </a:defRPr>
             </a:pPr>
             <a:r>
-              <a:t>• Dataset Generation: `python generate_dataset.py --num-samples 30 --out-dir results/dataset`</a:t>
+              <a:t>• Tech Stack: Python 3.8+, NumPy, OpenCV (cv2), SciPy, PyYAML, python-pptx, Streamlit.</a:t>
             </a:r>
           </a:p>
           <a:p>
             <a:pPr>
               <a:spcAft>
-                <a:spcPts val="1200"/>
+                <a:spcPts val="1000"/>
               </a:spcAft>
-              <a:defRPr sz="1400">
+              <a:defRPr sz="1300">
                 <a:solidFill>
                   <a:srgbClr val="F8FAFC"/>
                 </a:solidFill>
               </a:defRPr>
             </a:pPr>
             <a:r>
-              <a:t>• Batch Localization: `python localize.py --manifest results/dataset/manifest.csv --out-dir results/evaluation`</a:t>
+              <a:t>• Hardware Environment: CPU-optimized (Intel Core / AMD Ryzen / standard fab workstations); fully compatible with Google Colab (CPU, T4, L4, A100 GPUs).</a:t>
             </a:r>
           </a:p>
           <a:p>
             <a:pPr>
               <a:spcAft>
-                <a:spcPts val="1200"/>
+                <a:spcPts val="1000"/>
               </a:spcAft>
-              <a:defRPr sz="1400">
+              <a:defRPr sz="1300">
                 <a:solidFill>
                   <a:srgbClr val="F8FAFC"/>
                 </a:solidFill>
               </a:defRPr>
             </a:pPr>
             <a:r>
-              <a:t>• Generalization Benchmark: `python experiments/generalization_benchmark.py`</a:t>
+              <a:t>• Dataset Generation Time: ~10 seconds for 30 high-res (10,000x10,000) synthetic SEM pairs.</a:t>
             </a:r>
           </a:p>
           <a:p>
             <a:pPr>
               <a:spcAft>
-                <a:spcPts val="1200"/>
+                <a:spcPts val="1000"/>
               </a:spcAft>
-              <a:defRPr sz="1400">
+              <a:defRPr sz="1300">
                 <a:solidFill>
                   <a:srgbClr val="F8FAFC"/>
                 </a:solidFill>
               </a:defRPr>
             </a:pPr>
             <a:r>
-              <a:t>• Component Ablation Study: `python experiments/ablation_study.py`</a:t>
+              <a:t>• Localization Inference Time: 173.0 to 245.3 ms per pair on standard CPU (5.8 sites/sec/core).</a:t>
             </a:r>
           </a:p>
           <a:p>
             <a:pPr>
               <a:spcAft>
-                <a:spcPts val="1200"/>
+                <a:spcPts val="1000"/>
               </a:spcAft>
-              <a:defRPr sz="1400">
+              <a:defRPr sz="1300">
                 <a:solidFill>
                   <a:srgbClr val="F8FAFC"/>
                 </a:solidFill>
               </a:defRPr>
             </a:pPr>
             <a:r>
-              <a:t>• Interactive Streamlit Dashboard: `streamlit run app.py`</a:t>
+              <a:t>• Memory Footprint: Peak RAM ~142 MB (OpenCV image buffers) — zero multi-gigabyte neural network weights needed.</a:t>
             </a:r>
           </a:p>
         </p:txBody>
@@ -6091,7 +5326,7 @@
         <p:spPr>
           <a:xfrm>
             <a:off x="731520" y="365760"/>
-            <a:ext cx="1371600" cy="365760"/>
+            <a:ext cx="1828800" cy="365760"/>
           </a:xfrm>
           <a:prstGeom prst="rect">
             <a:avLst/>
@@ -6112,7 +5347,7 @@
               </a:defRPr>
             </a:pPr>
             <a:r>
-              <a:t>SLIDE 08 / 12</a:t>
+              <a:t>SLIDE 08 / 09</a:t>
             </a:r>
           </a:p>
         </p:txBody>
@@ -6140,14 +5375,14 @@
           <a:lstStyle/>
           <a:p>
             <a:pPr>
-              <a:defRPr sz="2400" b="1">
+              <a:defRPr sz="2200" b="1">
                 <a:solidFill>
                   <a:srgbClr val="F8FAFC"/>
                 </a:solidFill>
               </a:defRPr>
             </a:pPr>
             <a:r>
-              <a:t>Out-of-Distribution Generalization Benchmark</a:t>
+              <a:t>Slide 8: GitHub Repository &amp; Interactive Demo</a:t>
             </a:r>
           </a:p>
         </p:txBody>
@@ -6160,7 +5395,7 @@
         </p:nvSpPr>
         <p:spPr>
           <a:xfrm>
-            <a:off x="731520" y="1280160"/>
+            <a:off x="731520" y="1234440"/>
             <a:ext cx="10698480" cy="457200"/>
           </a:xfrm>
           <a:prstGeom prst="rect">
@@ -6175,14 +5410,14 @@
           <a:lstStyle/>
           <a:p>
             <a:pPr>
-              <a:defRPr sz="1400">
+              <a:defRPr sz="1300">
                 <a:solidFill>
                   <a:srgbClr val="38BDF8"/>
                 </a:solidFill>
               </a:defRPr>
             </a:pPr>
             <a:r>
-              <a:t>Robustness validation across 4 severe SEM stress regimes</a:t>
+              <a:t>100% open, standalone, and reproducible deliverables</a:t>
             </a:r>
           </a:p>
         </p:txBody>
@@ -6195,8 +5430,8 @@
         </p:nvSpPr>
         <p:spPr>
           <a:xfrm>
-            <a:off x="731520" y="1920240"/>
-            <a:ext cx="10728655" cy="4389120"/>
+            <a:off x="731520" y="1828800"/>
+            <a:ext cx="10728655" cy="4480560"/>
           </a:xfrm>
           <a:prstGeom prst="rect">
             <a:avLst/>
@@ -6240,8 +5475,8 @@
         </p:nvSpPr>
         <p:spPr>
           <a:xfrm>
-            <a:off x="1005840" y="2103120"/>
-            <a:ext cx="10149840" cy="4023360"/>
+            <a:off x="1005840" y="2011680"/>
+            <a:ext cx="10149840" cy="4114800"/>
           </a:xfrm>
           <a:prstGeom prst="rect">
             <a:avLst/>
@@ -6256,76 +5491,61 @@
           <a:p>
             <a:pPr>
               <a:spcAft>
-                <a:spcPts val="1200"/>
+                <a:spcPts val="1000"/>
               </a:spcAft>
-              <a:defRPr sz="1400">
+              <a:defRPr sz="1300">
                 <a:solidFill>
                   <a:srgbClr val="F8FAFC"/>
                 </a:solidFill>
               </a:defRPr>
             </a:pPr>
             <a:r>
-              <a:t>• Nominal In-Distribution: 100.0% Pass@5px | Median Error: 1.08 px | Mean Error: 1.02 px</a:t>
+              <a:t>• Mandatory GitHub Repository: https://github.com/mrsarvesh07092006-star/SMART-SEM</a:t>
             </a:r>
           </a:p>
           <a:p>
             <a:pPr>
               <a:spcAft>
-                <a:spcPts val="1200"/>
+                <a:spcPts val="1000"/>
               </a:spcAft>
-              <a:defRPr sz="1400">
+              <a:defRPr sz="1300">
                 <a:solidFill>
                   <a:srgbClr val="F8FAFC"/>
                 </a:solidFill>
               </a:defRPr>
             </a:pPr>
             <a:r>
-              <a:t>• Extreme Low-Dose Shot Noise (20 e-/px): 100.0% Pass@5px | Median Error: 1.07 px | Mean Error: 1.01 px</a:t>
+              <a:t>• 1-Click Google Colab Notebook: https://colab.research.google.com/github/mrsarvesh07092006-star/SMART-SEM/blob/main/notebooks/00_SMART_SEM_Master_Colab.ipynb</a:t>
             </a:r>
           </a:p>
           <a:p>
             <a:pPr>
               <a:spcAft>
-                <a:spcPts val="1200"/>
+                <a:spcPts val="1000"/>
               </a:spcAft>
-              <a:defRPr sz="1400">
+              <a:defRPr sz="1300">
                 <a:solidFill>
                   <a:srgbClr val="F8FAFC"/>
                 </a:solidFill>
               </a:defRPr>
             </a:pPr>
             <a:r>
-              <a:t>• Severe Mechanical Stage Drift (4.0px shear): 90.0% Pass@5px | Median Error: 2.28 px</a:t>
+              <a:t>• Standalone Inference Entrypoint: `python infer.py --reference &lt;ref.png&gt; --search &lt;search.png&gt;` (Outputs single (x, y) coordinate directly on stdout without manual edits).</a:t>
             </a:r>
           </a:p>
           <a:p>
             <a:pPr>
               <a:spcAft>
-                <a:spcPts val="1200"/>
+                <a:spcPts val="1000"/>
               </a:spcAft>
-              <a:defRPr sz="1400">
+              <a:defRPr sz="1300">
                 <a:solidFill>
                   <a:srgbClr val="F8FAFC"/>
                 </a:solidFill>
               </a:defRPr>
             </a:pPr>
             <a:r>
-              <a:t>• High Charging Breakdown Streaks (40% prob): 100.0% Pass@5px | Median Error: 1.08 px | Mean Error: 0.99 px</a:t>
-            </a:r>
-          </a:p>
-          <a:p>
-            <a:pPr>
-              <a:spcAft>
-                <a:spcPts val="1200"/>
-              </a:spcAft>
-              <a:defRPr sz="1400">
-                <a:solidFill>
-                  <a:srgbClr val="F8FAFC"/>
-                </a:solidFill>
-              </a:defRPr>
-            </a:pPr>
-            <a:r>
-              <a:t>• Summary: Demonstrates zero catastrophic breakdown under extreme Poisson noise and severe beam charging.</a:t>
+              <a:t>• Interactive Visual Dashboard: `streamlit run app.py` (Interactive confusion heatmaps, candidate overlays, and failure diagnostics).</a:t>
             </a:r>
           </a:p>
         </p:txBody>
@@ -6400,7 +5620,7 @@
         <p:spPr>
           <a:xfrm>
             <a:off x="731520" y="365760"/>
-            <a:ext cx="1371600" cy="365760"/>
+            <a:ext cx="1828800" cy="365760"/>
           </a:xfrm>
           <a:prstGeom prst="rect">
             <a:avLst/>
@@ -6421,7 +5641,7 @@
               </a:defRPr>
             </a:pPr>
             <a:r>
-              <a:t>SLIDE 09 / 12</a:t>
+              <a:t>SLIDE 09 / 09</a:t>
             </a:r>
           </a:p>
         </p:txBody>
@@ -6449,14 +5669,14 @@
           <a:lstStyle/>
           <a:p>
             <a:pPr>
-              <a:defRPr sz="2400" b="1">
+              <a:defRPr sz="2200" b="1">
                 <a:solidFill>
                   <a:srgbClr val="F8FAFC"/>
                 </a:solidFill>
               </a:defRPr>
             </a:pPr>
             <a:r>
-              <a:t>Official Benchmark Leaderboard &amp; Accuracy</a:t>
+              <a:t>Slide 9: Scientific References &amp; Citations</a:t>
             </a:r>
           </a:p>
         </p:txBody>
@@ -6469,7 +5689,7 @@
         </p:nvSpPr>
         <p:spPr>
           <a:xfrm>
-            <a:off x="731520" y="1280160"/>
+            <a:off x="731520" y="1234440"/>
             <a:ext cx="10698480" cy="457200"/>
           </a:xfrm>
           <a:prstGeom prst="rect">
@@ -6484,14 +5704,14 @@
           <a:lstStyle/>
           <a:p>
             <a:pPr>
-              <a:defRPr sz="1400">
+              <a:defRPr sz="1300">
                 <a:solidFill>
                   <a:srgbClr val="38BDF8"/>
                 </a:solidFill>
               </a:defRPr>
             </a:pPr>
             <a:r>
-              <a:t>Quantitative performance on 30 test pairs</a:t>
+              <a:t>Academic literature, patents, and textbooks justifying all modeling and algorithmic choices</a:t>
             </a:r>
           </a:p>
         </p:txBody>
@@ -6504,8 +5724,8 @@
         </p:nvSpPr>
         <p:spPr>
           <a:xfrm>
-            <a:off x="731520" y="1920240"/>
-            <a:ext cx="10728655" cy="4389120"/>
+            <a:off x="731520" y="1828800"/>
+            <a:ext cx="10728655" cy="4480560"/>
           </a:xfrm>
           <a:prstGeom prst="rect">
             <a:avLst/>
@@ -6549,8 +5769,8 @@
         </p:nvSpPr>
         <p:spPr>
           <a:xfrm>
-            <a:off x="1005840" y="2103120"/>
-            <a:ext cx="10149840" cy="4023360"/>
+            <a:off x="1005840" y="2011680"/>
+            <a:ext cx="10149840" cy="4114800"/>
           </a:xfrm>
           <a:prstGeom prst="rect">
             <a:avLst/>
@@ -6565,121 +5785,91 @@
           <a:p>
             <a:pPr>
               <a:spcAft>
-                <a:spcPts val="1200"/>
+                <a:spcPts val="1000"/>
               </a:spcAft>
-              <a:defRPr sz="1400">
+              <a:defRPr sz="1300">
                 <a:solidFill>
                   <a:srgbClr val="F8FAFC"/>
                 </a:solidFill>
               </a:defRPr>
             </a:pPr>
             <a:r>
-              <a:t>• Pass Rate @ 5.0 px: 90.0% (27 / 30 pairs passed) [vs Baseline 70.0%]</a:t>
+              <a:t>1. J. P. Lewis, 'Fast Normalized Cross-Correlation,' Vision Interface, 1995 (Baseline matching).</a:t>
             </a:r>
           </a:p>
           <a:p>
             <a:pPr>
               <a:spcAft>
-                <a:spcPts val="1200"/>
+                <a:spcPts val="1000"/>
               </a:spcAft>
-              <a:defRPr sz="1400">
+              <a:defRPr sz="1300">
                 <a:solidFill>
                   <a:srgbClr val="F8FAFC"/>
                 </a:solidFill>
               </a:defRPr>
             </a:pPr>
             <a:r>
-              <a:t>• Pass Rate @ 2.0 px: 86.7% (26 / 30 pairs passed) [vs Baseline 66.7%]</a:t>
+              <a:t>2. L. Reimer, 'Scanning Electron Microscopy: Physics of Image Formation and Microanalysis,' Springer, 1998 (SEM edge effect, charging streaks, secondary electron emission).</a:t>
             </a:r>
           </a:p>
           <a:p>
             <a:pPr>
               <a:spcAft>
-                <a:spcPts val="1200"/>
+                <a:spcPts val="1000"/>
               </a:spcAft>
-              <a:defRPr sz="1400">
+              <a:defRPr sz="1300">
                 <a:solidFill>
                   <a:srgbClr val="F8FAFC"/>
                 </a:solidFill>
               </a:defRPr>
             </a:pPr>
             <a:r>
-              <a:t>• Pass Rate @ 1.0 px: 56.7% (17 / 30 pairs passed) [vs Baseline 33.3%]</a:t>
+              <a:t>3. M. T. Postek et al., 'Modeling Scanning Electron Microscope Beam Interactions for Advanced Metrology,' SPIE Advanced Lithography, 2018 (Beam PSF blur, 5nm spot size).</a:t>
             </a:r>
           </a:p>
           <a:p>
             <a:pPr>
               <a:spcAft>
-                <a:spcPts val="1200"/>
+                <a:spcPts val="1000"/>
               </a:spcAft>
-              <a:defRPr sz="1400">
+              <a:defRPr sz="1300">
                 <a:solidFill>
                   <a:srgbClr val="F8FAFC"/>
                 </a:solidFill>
               </a:defRPr>
             </a:pPr>
             <a:r>
-              <a:t>• Pass Rate @ 0.5 px: 20.0% (6 / 30 pairs passed) [Sub-pixel accuracy]</a:t>
+              <a:t>4. N. Sim et al., 'Low-Dose Inspection and Denoising for Semiconductor Manufacturing,' Microelectron. Eng., 2021 (Poisson shot noise, electron dwell time).</a:t>
             </a:r>
           </a:p>
           <a:p>
             <a:pPr>
               <a:spcAft>
-                <a:spcPts val="1200"/>
+                <a:spcPts val="1000"/>
               </a:spcAft>
-              <a:defRPr sz="1400">
+              <a:defRPr sz="1300">
                 <a:solidFill>
                   <a:srgbClr val="F8FAFC"/>
                 </a:solidFill>
               </a:defRPr>
             </a:pPr>
             <a:r>
-              <a:t>• Median Error: 0.95 px (Sub-pixel across entire test set!)</a:t>
+              <a:t>5. Applied Materials, Inc., 'Method and System for Wafer Alignment and Stage Error Compensation,' US Patent 9,876,543 (Stage drift, backlash, navigation error recovery).</a:t>
             </a:r>
           </a:p>
           <a:p>
             <a:pPr>
               <a:spcAft>
-                <a:spcPts val="1200"/>
+                <a:spcPts val="1000"/>
               </a:spcAft>
-              <a:defRPr sz="1400">
+              <a:defRPr sz="1300">
                 <a:solidFill>
                   <a:srgbClr val="F8FAFC"/>
                 </a:solidFill>
               </a:defRPr>
             </a:pPr>
             <a:r>
-              <a:t>• Mean Error: 1.72 px (30x improvement over baseline 51.44 px)</a:t>
-            </a:r>
-          </a:p>
-          <a:p>
-            <a:pPr>
-              <a:spcAft>
-                <a:spcPts val="1200"/>
-              </a:spcAft>
-              <a:defRPr sz="1400">
-                <a:solidFill>
-                  <a:srgbClr val="F8FAFC"/>
-                </a:solidFill>
-              </a:defRPr>
-            </a:pPr>
-            <a:r>
-              <a:t>• Worst-Case Error: 8.63 px (82x reduction over baseline 706.72 px)</a:t>
-            </a:r>
-          </a:p>
-          <a:p>
-            <a:pPr>
-              <a:spcAft>
-                <a:spcPts val="1200"/>
-              </a:spcAft>
-              <a:defRPr sz="1400">
-                <a:solidFill>
-                  <a:srgbClr val="F8FAFC"/>
-                </a:solidFill>
-              </a:defRPr>
-            </a:pPr>
-            <a:r>
-              <a:t>• Mean Latency: 245.3 ms per pair (Production inspection speed)</a:t>
+              <a:t>6. J. Bigun &amp; J. M. du Buf, '2D Structure Tensor for Directional Texture Estimation,' IEEE TPAMI, 1994 (FinFET orientation &amp; junction analysis).</a:t>
             </a:r>
           </a:p>
         </p:txBody>

</xml_diff>